<commit_message>
Add Black Ops tiger-team concept (09) + aviation airport worked engagement (10); extend deck to 26 slides; cross-links
Co-authored-by: Cursor <cursoragent@cursor.com>
</commit_message>
<xml_diff>
--- a/Field-CTO-XArch-Business-Case.pptx
+++ b/Field-CTO-XArch-Business-Case.pptx
@@ -29,6 +29,8 @@
     <p:sldId id="277" r:id="rId29"/>
     <p:sldId id="278" r:id="rId30"/>
     <p:sldId id="279" r:id="rId31"/>
+    <p:sldId id="280" r:id="rId32"/>
+    <p:sldId id="281" r:id="rId33"/>
   </p:sldIdLst>
   <p:sldSz cx="12191695" cy="6858000" type="screen4x3"/>
   <p:notesSz cx="6858000" cy="9144000"/>
@@ -595,7 +597,7 @@
           <a:lstStyle/>
           <a:p>
             <a:r>
-              <a:t>Show this is systematized, not dependent on a few heroes. The play library codifies the knowledge so the motion scales and survives key-person risk. Source: 05 §1–2.</a:t>
+              <a:t>Chosen on three criteria: high cross-attach, strong regulatory/resilience pull, and joint Cisco+Splunk strength. The list is swappable without changing the operating design. Source: 02 §5; 04 master matrix.</a:t>
             </a:r>
           </a:p>
         </p:txBody>
@@ -665,7 +667,7 @@
           <a:lstStyle/>
           <a:p>
             <a:r>
-              <a:t>The money slide. Anchor on break-even: ~$9M bookings (about five deals) covers the entire $5.4M cost; everything above is upside. Reinforce these are illustrative and parameterized. Source: 01 §6; 06 §2–3.</a:t>
+              <a:t>Show this is systematized, not dependent on a few heroes. The play library codifies the knowledge so the motion scales and survives key-person risk. Source: 05 §1–2.</a:t>
             </a:r>
           </a:p>
         </p:txBody>
@@ -735,7 +737,7 @@
           <a:lstStyle/>
           <a:p>
             <a:r>
-              <a:t>State the ask plainly and immediately bound the downside: small, senior team; defined spend; a real stop gate at Q3. Ask for the decision. Source: 01 §5; 06 §1.</a:t>
+              <a:t>The end-to-end proof. Walk the transformation: stalled + SI-locked → executive breakthrough → one co-authored architecture → multi-year program. Stress the OT safety boundary as the trust-winner with airport engineering. Source: 10.</a:t>
             </a:r>
           </a:p>
         </p:txBody>
@@ -805,7 +807,7 @@
           <a:lstStyle/>
           <a:p>
             <a:r>
-              <a:t>De-risk the financials. The three scenarios all clear break-even; the difference is how fast we scale, not whether it pays back. Source: 06 §5.</a:t>
+              <a:t>The money slide. Anchor on break-even: ~$9M bookings (about five deals) covers the entire $5.4M cost; everything above is upside. Reinforce these are illustrative and parameterized. Source: 01 §6; 06 §2–3.</a:t>
             </a:r>
           </a:p>
         </p:txBody>
@@ -875,7 +877,7 @@
           <a:lstStyle/>
           <a:p>
             <a:r>
-              <a:t>Address the skeptic. We measure with control accounts, so influence is proven not asserted; and we can stop at Q3 if the deltas aren't there. Source: 07 §1–3; 05 §7.</a:t>
+              <a:t>State the ask plainly and immediately bound the downside: small, senior team; defined spend; a real stop gate at Q3. Ask for the decision. Source: 01 §5; 06 §1.</a:t>
             </a:r>
           </a:p>
         </p:txBody>
@@ -945,7 +947,7 @@
           <a:lstStyle/>
           <a:p>
             <a:r>
-              <a:t>Close with a clear call to action and a concrete near-term timeline so approval feels actionable, not open-ended. Restate: bounded downside, differentiated upside. Ask for the yes. Source: 01 §9; README one-screen summary.</a:t>
+              <a:t>De-risk the financials. The three scenarios all clear break-even; the difference is how fast we scale, not whether it pays back. Source: 06 §5.</a:t>
             </a:r>
           </a:p>
         </p:txBody>
@@ -1015,7 +1017,7 @@
           <a:lstStyle/>
           <a:p>
             <a:r>
-              <a:t>Use these only if the room asks. Don't present them by default.</a:t>
+              <a:t>Address the skeptic. We measure with control accounts, so influence is proven not asserted; and we can stop at Q3 if the deltas aren't there. Source: 07 §1–3; 05 §7.</a:t>
             </a:r>
           </a:p>
         </p:txBody>
@@ -1085,7 +1087,7 @@
           <a:lstStyle/>
           <a:p>
             <a:r>
-              <a:t>Detail for HR/org-design questions. Source: 03 §1–3.</a:t>
+              <a:t>Close with a clear call to action and a concrete near-term timeline so approval feels actionable, not open-ended. Restate: bounded downside, differentiated upside. Ask for the yes. Source: 01 §9; README one-screen summary.</a:t>
             </a:r>
           </a:p>
         </p:txBody>
@@ -1155,7 +1157,7 @@
           <a:lstStyle/>
           <a:p>
             <a:r>
-              <a:t>For 'where does it sit / who owns what' questions. Source: 03 §5, §8.</a:t>
+              <a:t>Use these only if the room asks. Don't present them by default.</a:t>
             </a:r>
           </a:p>
         </p:txBody>
@@ -1225,7 +1227,7 @@
           <a:lstStyle/>
           <a:p>
             <a:r>
-              <a:t>For 'how do we actually sell this' questions. Source: 04 §1–4.</a:t>
+              <a:t>Detail for HR/org-design questions. Source: 03 §1–3.</a:t>
             </a:r>
           </a:p>
         </p:txBody>
@@ -1365,7 +1367,7 @@
           <a:lstStyle/>
           <a:p>
             <a:r>
-              <a:t>For OT/operations stakeholders. Source: 04 OT safety boundary.</a:t>
+              <a:t>For 'where does it sit / who owns what' questions. Source: 03 §5, §8.</a:t>
             </a:r>
           </a:p>
         </p:txBody>
@@ -1435,7 +1437,7 @@
           <a:lstStyle/>
           <a:p>
             <a:r>
-              <a:t>For finance deep-dives. Source: 06 §0, §4.</a:t>
+              <a:t>For 'how do we actually sell this' questions. Source: 04 §1–4.</a:t>
             </a:r>
           </a:p>
         </p:txBody>
@@ -1505,7 +1507,7 @@
           <a:lstStyle/>
           <a:p>
             <a:r>
-              <a:t>For comp/quota questions. Source: 05 §6.</a:t>
+              <a:t>For OT/operations stakeholders. Source: 04 OT safety boundary.</a:t>
             </a:r>
           </a:p>
         </p:txBody>
@@ -1575,7 +1577,7 @@
           <a:lstStyle/>
           <a:p>
             <a:r>
-              <a:t>For competitive/positioning questions. Source: 02 §7.</a:t>
+              <a:t>For finance deep-dives. Source: 06 §0, §4.</a:t>
             </a:r>
           </a:p>
         </p:txBody>
@@ -1645,6 +1647,146 @@
           <a:lstStyle/>
           <a:p>
             <a:r>
+              <a:t>For comp/quota questions. Source: 05 §6.</a:t>
+            </a:r>
+          </a:p>
+        </p:txBody>
+      </p:sp>
+      <p:sp>
+        <p:nvSpPr>
+          <p:cNvPr id="4" name="Slide Number Placeholder 3"/>
+          <p:cNvSpPr>
+            <a:spLocks noGrp="1"/>
+          </p:cNvSpPr>
+          <p:nvPr>
+            <p:ph type="sldNum" idx="5" sz="quarter"/>
+          </p:nvPr>
+        </p:nvSpPr>
+        <p:spPr/>
+      </p:sp>
+    </p:spTree>
+  </p:cSld>
+  <p:clrMapOvr>
+    <a:masterClrMapping/>
+  </p:clrMapOvr>
+</p:notes>
+</file>
+
+<file path=ppt/notesSlides/notesSlide25.xml><?xml version="1.0" encoding="utf-8"?>
+<p:notes xmlns:a="http://schemas.openxmlformats.org/drawingml/2006/main" xmlns:p="http://schemas.openxmlformats.org/presentationml/2006/main" xmlns:r="http://schemas.openxmlformats.org/officeDocument/2006/relationships">
+  <p:cSld>
+    <p:spTree>
+      <p:nvGrpSpPr>
+        <p:cNvPr id="1" name=""/>
+        <p:cNvGrpSpPr/>
+        <p:nvPr/>
+      </p:nvGrpSpPr>
+      <p:grpSpPr>
+        <a:xfrm>
+          <a:off x="0" y="0"/>
+          <a:ext cx="0" cy="0"/>
+          <a:chOff x="0" y="0"/>
+          <a:chExt cx="0" cy="0"/>
+        </a:xfrm>
+      </p:grpSpPr>
+      <p:sp>
+        <p:nvSpPr>
+          <p:cNvPr id="2" name="Slide Image Placeholder 1"/>
+          <p:cNvSpPr>
+            <a:spLocks noGrp="1"/>
+          </p:cNvSpPr>
+          <p:nvPr>
+            <p:ph type="sldImg" idx="2"/>
+          </p:nvPr>
+        </p:nvSpPr>
+        <p:spPr/>
+      </p:sp>
+      <p:sp>
+        <p:nvSpPr>
+          <p:cNvPr id="3" name="Notes Placeholder 2"/>
+          <p:cNvSpPr>
+            <a:spLocks noGrp="1"/>
+          </p:cNvSpPr>
+          <p:nvPr>
+            <p:ph type="body" idx="3" sz="quarter"/>
+          </p:nvPr>
+        </p:nvSpPr>
+        <p:spPr/>
+        <p:txBody>
+          <a:bodyPr/>
+          <a:lstStyle/>
+          <a:p>
+            <a:r>
+              <a:t>For competitive/positioning questions. Source: 02 §7.</a:t>
+            </a:r>
+          </a:p>
+        </p:txBody>
+      </p:sp>
+      <p:sp>
+        <p:nvSpPr>
+          <p:cNvPr id="4" name="Slide Number Placeholder 3"/>
+          <p:cNvSpPr>
+            <a:spLocks noGrp="1"/>
+          </p:cNvSpPr>
+          <p:nvPr>
+            <p:ph type="sldNum" idx="5" sz="quarter"/>
+          </p:nvPr>
+        </p:nvSpPr>
+        <p:spPr/>
+      </p:sp>
+    </p:spTree>
+  </p:cSld>
+  <p:clrMapOvr>
+    <a:masterClrMapping/>
+  </p:clrMapOvr>
+</p:notes>
+</file>
+
+<file path=ppt/notesSlides/notesSlide26.xml><?xml version="1.0" encoding="utf-8"?>
+<p:notes xmlns:a="http://schemas.openxmlformats.org/drawingml/2006/main" xmlns:p="http://schemas.openxmlformats.org/presentationml/2006/main" xmlns:r="http://schemas.openxmlformats.org/officeDocument/2006/relationships">
+  <p:cSld>
+    <p:spTree>
+      <p:nvGrpSpPr>
+        <p:cNvPr id="1" name=""/>
+        <p:cNvGrpSpPr/>
+        <p:nvPr/>
+      </p:nvGrpSpPr>
+      <p:grpSpPr>
+        <a:xfrm>
+          <a:off x="0" y="0"/>
+          <a:ext cx="0" cy="0"/>
+          <a:chOff x="0" y="0"/>
+          <a:chExt cx="0" cy="0"/>
+        </a:xfrm>
+      </p:grpSpPr>
+      <p:sp>
+        <p:nvSpPr>
+          <p:cNvPr id="2" name="Slide Image Placeholder 1"/>
+          <p:cNvSpPr>
+            <a:spLocks noGrp="1"/>
+          </p:cNvSpPr>
+          <p:nvPr>
+            <p:ph type="sldImg" idx="2"/>
+          </p:nvPr>
+        </p:nvSpPr>
+        <p:spPr/>
+      </p:sp>
+      <p:sp>
+        <p:nvSpPr>
+          <p:cNvPr id="3" name="Notes Placeholder 2"/>
+          <p:cNvSpPr>
+            <a:spLocks noGrp="1"/>
+          </p:cNvSpPr>
+          <p:nvPr>
+            <p:ph type="body" idx="3" sz="quarter"/>
+          </p:nvPr>
+        </p:nvSpPr>
+        <p:spPr/>
+        <p:txBody>
+          <a:bodyPr/>
+          <a:lstStyle/>
+          <a:p>
+            <a:r>
               <a:t>For risk/governance questions. Source: 07 §3.</a:t>
             </a:r>
           </a:p>
@@ -1995,7 +2137,7 @@
           <a:lstStyle/>
           <a:p>
             <a:r>
-              <a:t>The port-operator vignette makes the abstract concrete. Contrast the two paths visually. The punchline: the customer co-authors the architecture, so Cisco is the partner, not one of several suppliers. Source: 01 §3 vignette.</a:t>
+              <a:t>Introduce the tiger team as a mode, not separate headcount. Emphasize two things: it always hands the account back (no hoarding), and 'Black Ops' is a special-forces posture metaphor — fully ethical, nothing hidden from the customer. Source: 09.</a:t>
             </a:r>
           </a:p>
         </p:txBody>
@@ -2065,7 +2207,7 @@
           <a:lstStyle/>
           <a:p>
             <a:r>
-              <a:t>We deliberately don't boil the ocean. Three anchor pillars with the clearest boardroom narrative, plus AI-ready infra as an adjacency. Collaboration and pure compute are attach, not lead. Source: 02 §4.</a:t>
+              <a:t>The port-operator vignette makes the abstract concrete. Contrast the two paths visually. The punchline: the customer co-authors the architecture, so Cisco is the partner, not one of several suppliers. Source: 01 §3 vignette.</a:t>
             </a:r>
           </a:p>
         </p:txBody>
@@ -2135,7 +2277,7 @@
           <a:lstStyle/>
           <a:p>
             <a:r>
-              <a:t>Chosen on three criteria: high cross-attach, strong regulatory/resilience pull, and joint Cisco+Splunk strength. The list is swappable without changing the operating design. Source: 02 §5; 04 master matrix.</a:t>
+              <a:t>We deliberately don't boil the ocean. Three anchor pillars with the clearest boardroom narrative, plus AI-ready infra as an adjacency. Collaboration and pure compute are attach, not lead. Source: 02 §4.</a:t>
             </a:r>
           </a:p>
         </p:txBody>
@@ -5480,7 +5622,7 @@
                 </a:solidFill>
                 <a:latin typeface="Calibri"/>
               </a:rPr>
-              <a:t>THE MOTION</a:t>
+              <a:t>FOCUS · VERTICALS</a:t>
             </a:r>
           </a:p>
         </p:txBody>
@@ -5562,7 +5704,7 @@
                 </a:solidFill>
                 <a:latin typeface="Calibri"/>
               </a:rPr>
-              <a:t>A repeatable lifecycle and a library of plays — not heroics</a:t>
+              <a:t>Four verticals chosen for cross-attach and regulatory pull</a:t>
             </a:r>
           </a:p>
         </p:txBody>
@@ -5655,7 +5797,7 @@
                 </a:solidFill>
                 <a:latin typeface="Calibri"/>
               </a:rPr>
-              <a:t>Select &amp; trigger → Executive framing → X-Arch architecture</a:t>
+              <a:t>Transportation &amp; Logistics — distributed sites, IoT, transport-OT (NIS2)</a:t>
             </a:r>
           </a:p>
           <a:p>
@@ -5680,7 +5822,7 @@
                 </a:solidFill>
                 <a:latin typeface="Calibri"/>
               </a:rPr>
-              <a:t>→ Value case → Orchestrate &amp; close → Land &amp; expand</a:t>
+              <a:t>Financial Services — resilience (DORA), fraud, SecOps, observability</a:t>
             </a:r>
           </a:p>
           <a:p>
@@ -5705,7 +5847,7 @@
                 </a:solidFill>
                 <a:latin typeface="Calibri"/>
               </a:rPr>
-              <a:t>Plays: Splunk-attach-to-network, SOC modernization, full-stack DX, passive OT, consolidation TCO</a:t>
+              <a:t>Healthcare — IoMT security, clinical-app observability, HIPAA</a:t>
             </a:r>
           </a:p>
           <a:p>
@@ -5730,7 +5872,7 @@
                 </a:solidFill>
                 <a:latin typeface="Calibri"/>
               </a:rPr>
-              <a:t>Each play = discovery script + reference architecture + value case + proof points</a:t>
+              <a:t>Public Sector / Critical Infrastructure — NERC-CIP/NIS2, SOC modernization</a:t>
             </a:r>
           </a:p>
         </p:txBody>
@@ -5870,7 +6012,7 @@
                 </a:solidFill>
                 <a:latin typeface="Calibri"/>
               </a:rPr>
-              <a:t>THE RETURN</a:t>
+              <a:t>THE MOTION</a:t>
             </a:r>
           </a:p>
         </p:txBody>
@@ -5952,7 +6094,7 @@
                 </a:solidFill>
                 <a:latin typeface="Calibri"/>
               </a:rPr>
-              <a:t>~$180M influenced pipeline, ~$60M incremental bookings, payback &lt; 12 months</a:t>
+              <a:t>A repeatable lifecycle and a library of plays — not heroics</a:t>
             </a:r>
           </a:p>
         </p:txBody>
@@ -6045,7 +6187,7 @@
                 </a:solidFill>
                 <a:latin typeface="Calibri"/>
               </a:rPr>
-              <a:t>Year-1 targets (illustrative): $180M influenced pipeline</a:t>
+              <a:t>Select &amp; trigger → Executive framing → X-Arch architecture</a:t>
             </a:r>
           </a:p>
           <a:p>
@@ -6070,7 +6212,7 @@
                 </a:solidFill>
                 <a:latin typeface="Calibri"/>
               </a:rPr>
-              <a:t>~$60M incremental/accelerated bookings → ~$36M incremental gross margin</a:t>
+              <a:t>→ Value case → Orchestrate &amp; close → Land &amp; expand</a:t>
             </a:r>
           </a:p>
           <a:p>
@@ -6095,7 +6237,7 @@
                 </a:solidFill>
                 <a:latin typeface="Calibri"/>
               </a:rPr>
-              <a:t>Break-even at just ~$9M bookings — roughly FIVE deals cover the whole cost</a:t>
+              <a:t>Plays: Splunk-attach-to-network, SOC modernization, full-stack DX, passive OT, consolidation TCO</a:t>
             </a:r>
           </a:p>
           <a:p>
@@ -6120,7 +6262,7 @@
                 </a:solidFill>
                 <a:latin typeface="Calibri"/>
               </a:rPr>
-              <a:t>Splunk cross-attach and deal-size uplift are the leading indicators</a:t>
+              <a:t>Each play = discovery script + reference architecture + value case + proof points</a:t>
             </a:r>
           </a:p>
         </p:txBody>
@@ -6260,7 +6402,7 @@
                 </a:solidFill>
                 <a:latin typeface="Calibri"/>
               </a:rPr>
-              <a:t>THE ASK</a:t>
+              <a:t>WORKED EXAMPLE · AVIATION</a:t>
             </a:r>
           </a:p>
         </p:txBody>
@@ -6342,7 +6484,7 @@
                 </a:solidFill>
                 <a:latin typeface="Calibri"/>
               </a:rPr>
-              <a:t>Fund a 12-person, 4-quarter pilot (~$5.4M illustrative)</a:t>
+              <a:t>Airport operator: Black Ops broke open a stalled 'smart airport' program</a:t>
             </a:r>
           </a:p>
         </p:txBody>
@@ -6435,7 +6577,7 @@
                 </a:solidFill>
                 <a:latin typeface="Calibri"/>
               </a:rPr>
-              <a:t>8 Field CTOs + 1 group lead + 2 X-Arch architects + 1 deal desk/ops</a:t>
+              <a:t>OT-heavy hub (baggage, jet bridges, airfield lighting) + NIS2 + Terminal 4 build</a:t>
             </a:r>
           </a:p>
           <a:p>
@@ -6460,7 +6602,7 @@
                 </a:solidFill>
                 <a:latin typeface="Calibri"/>
               </a:rPr>
-              <a:t>Fully-loaded ~$5.4M/yr including enablement, tooling, travel</a:t>
+              <a:t>SI was about to lock the architecture — Black Ops criteria met, pod convened</a:t>
             </a:r>
           </a:p>
           <a:p>
@@ -6485,7 +6627,7 @@
                 </a:solidFill>
                 <a:latin typeface="Calibri"/>
               </a:rPr>
-              <a:t>Internal-first staffing; ~40–60 named accounts with paired controls</a:t>
+              <a:t>Executive breakthrough reframed it as board-level operational resilience</a:t>
             </a:r>
           </a:p>
           <a:p>
@@ -6510,7 +6652,32 @@
                 </a:solidFill>
                 <a:latin typeface="Calibri"/>
               </a:rPr>
-              <a:t>Q3 go/expand/stop gate tied to explicit success criteria</a:t>
+              <a:t>One X-Arch architecture: passive OT + segmentation + SD-WAN + modern SOC + edge AI</a:t>
+            </a:r>
+          </a:p>
+          <a:p>
+            <a:pPr algn="l">
+              <a:spcAft>
+                <a:spcPts val="1000"/>
+              </a:spcAft>
+            </a:pPr>
+            <a:r>
+              <a:rPr sz="1700" b="1">
+                <a:solidFill>
+                  <a:srgbClr val="00BCEB"/>
+                </a:solidFill>
+                <a:latin typeface="Calibri"/>
+              </a:rPr>
+              <a:t>•  </a:t>
+            </a:r>
+            <a:r>
+              <a:rPr sz="1700" b="0">
+                <a:solidFill>
+                  <a:srgbClr val="F2F4F8"/>
+                </a:solidFill>
+                <a:latin typeface="Calibri"/>
+              </a:rPr>
+              <a:t>Won OT engineering's trust via read-only, human-in-the-loop — then handed back to scale</a:t>
             </a:r>
           </a:p>
         </p:txBody>
@@ -6650,7 +6817,7 @@
                 </a:solidFill>
                 <a:latin typeface="Calibri"/>
               </a:rPr>
-              <a:t>IT PAYS BACK</a:t>
+              <a:t>THE RETURN</a:t>
             </a:r>
           </a:p>
         </p:txBody>
@@ -6732,7 +6899,7 @@
                 </a:solidFill>
                 <a:latin typeface="Calibri"/>
               </a:rPr>
-              <a:t>Profitable from conservative to upside — the question is pace, not payback</a:t>
+              <a:t>~$180M influenced pipeline, ~$60M incremental bookings, payback &lt; 12 months</a:t>
             </a:r>
           </a:p>
         </p:txBody>
@@ -6825,7 +6992,7 @@
                 </a:solidFill>
                 <a:latin typeface="Calibri"/>
               </a:rPr>
-              <a:t>Conservative ~$25M bookings → ~$9M net (continue, tune targeting)</a:t>
+              <a:t>Year-1 targets (illustrative): $180M influenced pipeline</a:t>
             </a:r>
           </a:p>
           <a:p>
@@ -6850,7 +7017,7 @@
                 </a:solidFill>
                 <a:latin typeface="Calibri"/>
               </a:rPr>
-              <a:t>Base (plan) ~$60M → ~$31M net (expand per 3-year path)</a:t>
+              <a:t>~$60M incremental/accelerated bookings → ~$36M incremental gross margin</a:t>
             </a:r>
           </a:p>
           <a:p>
@@ -6875,7 +7042,7 @@
                 </a:solidFill>
                 <a:latin typeface="Calibri"/>
               </a:rPr>
-              <a:t>Upside ~$90M → ~$46M net (accelerate hiring)</a:t>
+              <a:t>Break-even at just ~$9M bookings — roughly FIVE deals cover the whole cost</a:t>
             </a:r>
           </a:p>
           <a:p>
@@ -6900,7 +7067,7 @@
                 </a:solidFill>
                 <a:latin typeface="Calibri"/>
               </a:rPr>
-              <a:t>Even $20M @ 50% margin returns +$4.6M net — profitable across the range</a:t>
+              <a:t>Splunk cross-attach and deal-size uplift are the leading indicators</a:t>
             </a:r>
           </a:p>
         </p:txBody>
@@ -7040,7 +7207,7 @@
                 </a:solidFill>
                 <a:latin typeface="Calibri"/>
               </a:rPr>
-              <a:t>BOUNDED RISK + PROOF</a:t>
+              <a:t>THE ASK</a:t>
             </a:r>
           </a:p>
         </p:txBody>
@@ -7122,7 +7289,7 @@
                 </a:solidFill>
                 <a:latin typeface="Calibri"/>
               </a:rPr>
-              <a:t>A Q3 gate and control-account measurement make this low-risk</a:t>
+              <a:t>Fund a 12-person, 4-quarter pilot (~$5.4M illustrative)</a:t>
             </a:r>
           </a:p>
         </p:txBody>
@@ -7215,7 +7382,7 @@
                 </a:solidFill>
                 <a:latin typeface="Calibri"/>
               </a:rPr>
-              <a:t>Q3 go/expand/stop gate stops spend before it can turn negative</a:t>
+              <a:t>8 Field CTOs + 1 group lead + 2 X-Arch architects + 1 deal desk/ops</a:t>
             </a:r>
           </a:p>
           <a:p>
@@ -7240,7 +7407,7 @@
                 </a:solidFill>
                 <a:latin typeface="Calibri"/>
               </a:rPr>
-              <a:t>Proof by matched control accounts: attach, deal size, win rate deltas</a:t>
+              <a:t>Fully-loaded ~$5.4M/yr including enablement, tooling, travel</a:t>
             </a:r>
           </a:p>
           <a:p>
@@ -7265,7 +7432,7 @@
                 </a:solidFill>
                 <a:latin typeface="Calibri"/>
               </a:rPr>
-              <a:t>Top risks (talent, comp friction, attribution) have concrete mitigations</a:t>
+              <a:t>Internal-first staffing; ~40–60 named accounts with paired controls</a:t>
             </a:r>
           </a:p>
           <a:p>
@@ -7290,7 +7457,7 @@
                 </a:solidFill>
                 <a:latin typeface="Calibri"/>
               </a:rPr>
-              <a:t>Influence ledger prevents over-claiming and BU disputes</a:t>
+              <a:t>Q3 go/expand/stop gate tied to explicit success criteria</a:t>
             </a:r>
           </a:p>
         </p:txBody>
@@ -7430,7 +7597,7 @@
                 </a:solidFill>
                 <a:latin typeface="Calibri"/>
               </a:rPr>
-              <a:t>RECOMMENDATION</a:t>
+              <a:t>IT PAYS BACK</a:t>
             </a:r>
           </a:p>
         </p:txBody>
@@ -7512,7 +7679,7 @@
                 </a:solidFill>
                 <a:latin typeface="Calibri"/>
               </a:rPr>
-              <a:t>Approve the pilot; first executive framings within 90 days</a:t>
+              <a:t>Profitable from conservative to upside — the question is pace, not payback</a:t>
             </a:r>
           </a:p>
         </p:txBody>
@@ -7605,7 +7772,7 @@
                 </a:solidFill>
                 <a:latin typeface="Calibri"/>
               </a:rPr>
-              <a:t>Approve the 12-person, 4-quarter funded pilot with a Q3 gate</a:t>
+              <a:t>Conservative ~$25M bookings → ~$9M net (continue, tune targeting)</a:t>
             </a:r>
           </a:p>
           <a:p>
@@ -7630,7 +7797,7 @@
                 </a:solidFill>
                 <a:latin typeface="Calibri"/>
               </a:rPr>
-              <a:t>+30d: group lead named; charter, comp, metrics baselined</a:t>
+              <a:t>Base (plan) ~$60M → ~$31M net (expand per 3-year path)</a:t>
             </a:r>
           </a:p>
           <a:p>
@@ -7655,7 +7822,7 @@
                 </a:solidFill>
                 <a:latin typeface="Calibri"/>
               </a:rPr>
-              <a:t>+60d: cohort staffed (internal-first); accounts + controls selected</a:t>
+              <a:t>Upside ~$90M → ~$46M net (accelerate hiring)</a:t>
             </a:r>
           </a:p>
           <a:p>
@@ -7680,7 +7847,7 @@
                 </a:solidFill>
                 <a:latin typeface="Calibri"/>
               </a:rPr>
-              <a:t>+90d: first X-Arch opportunities framed; enablement ramp underway</a:t>
+              <a:t>Even $20M @ 50% margin returns +$4.6M net — profitable across the range</a:t>
             </a:r>
           </a:p>
         </p:txBody>
@@ -7794,8 +7961,8 @@
         </p:nvSpPr>
         <p:spPr>
           <a:xfrm>
-            <a:off x="731520" y="2743200"/>
-            <a:ext cx="10698480" cy="914400"/>
+            <a:off x="548640" y="411480"/>
+            <a:ext cx="11064240" cy="365760"/>
           </a:xfrm>
           <a:prstGeom prst="rect">
             <a:avLst/>
@@ -7814,27 +7981,70 @@
               </a:spcAft>
             </a:pPr>
             <a:r>
-              <a:rPr sz="1600" b="1">
+              <a:rPr sz="1200" b="1">
                 <a:solidFill>
                   <a:srgbClr val="00BCEB"/>
                 </a:solidFill>
                 <a:latin typeface="Calibri"/>
               </a:rPr>
-              <a:t>APPENDIX</a:t>
-            </a:r>
-          </a:p>
-        </p:txBody>
-      </p:sp>
-      <p:sp>
-        <p:nvSpPr>
-          <p:cNvPr id="4" name="TextBox 3"/>
+              <a:t>BOUNDED RISK + PROOF</a:t>
+            </a:r>
+          </a:p>
+        </p:txBody>
+      </p:sp>
+      <p:sp>
+        <p:nvSpPr>
+          <p:cNvPr id="4" name="Rectangle 3"/>
+          <p:cNvSpPr/>
+          <p:nvPr/>
+        </p:nvSpPr>
+        <p:spPr>
+          <a:xfrm>
+            <a:off x="548640" y="868680"/>
+            <a:ext cx="1280160" cy="50800"/>
+          </a:xfrm>
+          <a:prstGeom prst="rect">
+            <a:avLst/>
+          </a:prstGeom>
+          <a:solidFill>
+            <a:srgbClr val="00BCEB"/>
+          </a:solidFill>
+          <a:ln>
+            <a:noFill/>
+          </a:ln>
+        </p:spPr>
+        <p:style>
+          <a:lnRef idx="1">
+            <a:schemeClr val="accent1"/>
+          </a:lnRef>
+          <a:fillRef idx="3">
+            <a:schemeClr val="accent1"/>
+          </a:fillRef>
+          <a:effectRef idx="2">
+            <a:schemeClr val="accent1"/>
+          </a:effectRef>
+          <a:fontRef idx="minor">
+            <a:schemeClr val="lt1"/>
+          </a:fontRef>
+        </p:style>
+        <p:txBody>
+          <a:bodyPr rtlCol="0" anchor="ctr"/>
+          <a:lstStyle/>
+          <a:p>
+            <a:pPr algn="ctr"/>
+          </a:p>
+        </p:txBody>
+      </p:sp>
+      <p:sp>
+        <p:nvSpPr>
+          <p:cNvPr id="5" name="TextBox 4"/>
           <p:cNvSpPr txBox="1"/>
           <p:nvPr/>
         </p:nvSpPr>
         <p:spPr>
           <a:xfrm>
-            <a:off x="731520" y="3200400"/>
-            <a:ext cx="10698480" cy="914400"/>
+            <a:off x="548640" y="1051560"/>
+            <a:ext cx="11064240" cy="1005840"/>
           </a:xfrm>
           <a:prstGeom prst="rect">
             <a:avLst/>
@@ -7853,13 +8063,220 @@
               </a:spcAft>
             </a:pPr>
             <a:r>
-              <a:rPr sz="3000" b="1">
+              <a:rPr sz="2800" b="1">
                 <a:solidFill>
                   <a:srgbClr val="F2F4F8"/>
                 </a:solidFill>
                 <a:latin typeface="Calibri"/>
               </a:rPr>
-              <a:t>Detail held in reserve for Q&amp;A</a:t>
+              <a:t>A Q3 gate and control-account measurement make this low-risk</a:t>
+            </a:r>
+          </a:p>
+        </p:txBody>
+      </p:sp>
+      <p:sp>
+        <p:nvSpPr>
+          <p:cNvPr id="6" name="Rectangle 5"/>
+          <p:cNvSpPr/>
+          <p:nvPr/>
+        </p:nvSpPr>
+        <p:spPr>
+          <a:xfrm>
+            <a:off x="548640" y="2331720"/>
+            <a:ext cx="11064240" cy="3931920"/>
+          </a:xfrm>
+          <a:prstGeom prst="rect">
+            <a:avLst/>
+          </a:prstGeom>
+          <a:solidFill>
+            <a:srgbClr val="1A1A2E"/>
+          </a:solidFill>
+          <a:ln w="12700">
+            <a:solidFill>
+              <a:srgbClr val="2C2C3A"/>
+            </a:solidFill>
+          </a:ln>
+        </p:spPr>
+        <p:style>
+          <a:lnRef idx="1">
+            <a:schemeClr val="accent1"/>
+          </a:lnRef>
+          <a:fillRef idx="3">
+            <a:schemeClr val="accent1"/>
+          </a:fillRef>
+          <a:effectRef idx="2">
+            <a:schemeClr val="accent1"/>
+          </a:effectRef>
+          <a:fontRef idx="minor">
+            <a:schemeClr val="lt1"/>
+          </a:fontRef>
+        </p:style>
+        <p:txBody>
+          <a:bodyPr rtlCol="0" anchor="ctr"/>
+          <a:lstStyle/>
+          <a:p>
+            <a:pPr algn="ctr"/>
+          </a:p>
+        </p:txBody>
+      </p:sp>
+      <p:sp>
+        <p:nvSpPr>
+          <p:cNvPr id="7" name="TextBox 6"/>
+          <p:cNvSpPr txBox="1"/>
+          <p:nvPr/>
+        </p:nvSpPr>
+        <p:spPr>
+          <a:xfrm>
+            <a:off x="914400" y="2560320"/>
+            <a:ext cx="10332720" cy="3566160"/>
+          </a:xfrm>
+          <a:prstGeom prst="rect">
+            <a:avLst/>
+          </a:prstGeom>
+          <a:noFill/>
+        </p:spPr>
+        <p:txBody>
+          <a:bodyPr wrap="square" anchor="t">
+            <a:spAutoFit/>
+          </a:bodyPr>
+          <a:lstStyle/>
+          <a:p>
+            <a:pPr algn="l">
+              <a:spcAft>
+                <a:spcPts val="1000"/>
+              </a:spcAft>
+            </a:pPr>
+            <a:r>
+              <a:rPr sz="1700" b="1">
+                <a:solidFill>
+                  <a:srgbClr val="00BCEB"/>
+                </a:solidFill>
+                <a:latin typeface="Calibri"/>
+              </a:rPr>
+              <a:t>•  </a:t>
+            </a:r>
+            <a:r>
+              <a:rPr sz="1700" b="0">
+                <a:solidFill>
+                  <a:srgbClr val="F2F4F8"/>
+                </a:solidFill>
+                <a:latin typeface="Calibri"/>
+              </a:rPr>
+              <a:t>Q3 go/expand/stop gate stops spend before it can turn negative</a:t>
+            </a:r>
+          </a:p>
+          <a:p>
+            <a:pPr algn="l">
+              <a:spcAft>
+                <a:spcPts val="1000"/>
+              </a:spcAft>
+            </a:pPr>
+            <a:r>
+              <a:rPr sz="1700" b="1">
+                <a:solidFill>
+                  <a:srgbClr val="00BCEB"/>
+                </a:solidFill>
+                <a:latin typeface="Calibri"/>
+              </a:rPr>
+              <a:t>•  </a:t>
+            </a:r>
+            <a:r>
+              <a:rPr sz="1700" b="0">
+                <a:solidFill>
+                  <a:srgbClr val="F2F4F8"/>
+                </a:solidFill>
+                <a:latin typeface="Calibri"/>
+              </a:rPr>
+              <a:t>Proof by matched control accounts: attach, deal size, win rate deltas</a:t>
+            </a:r>
+          </a:p>
+          <a:p>
+            <a:pPr algn="l">
+              <a:spcAft>
+                <a:spcPts val="1000"/>
+              </a:spcAft>
+            </a:pPr>
+            <a:r>
+              <a:rPr sz="1700" b="1">
+                <a:solidFill>
+                  <a:srgbClr val="00BCEB"/>
+                </a:solidFill>
+                <a:latin typeface="Calibri"/>
+              </a:rPr>
+              <a:t>•  </a:t>
+            </a:r>
+            <a:r>
+              <a:rPr sz="1700" b="0">
+                <a:solidFill>
+                  <a:srgbClr val="F2F4F8"/>
+                </a:solidFill>
+                <a:latin typeface="Calibri"/>
+              </a:rPr>
+              <a:t>Top risks (talent, comp friction, attribution) have concrete mitigations</a:t>
+            </a:r>
+          </a:p>
+          <a:p>
+            <a:pPr algn="l">
+              <a:spcAft>
+                <a:spcPts val="1000"/>
+              </a:spcAft>
+            </a:pPr>
+            <a:r>
+              <a:rPr sz="1700" b="1">
+                <a:solidFill>
+                  <a:srgbClr val="00BCEB"/>
+                </a:solidFill>
+                <a:latin typeface="Calibri"/>
+              </a:rPr>
+              <a:t>•  </a:t>
+            </a:r>
+            <a:r>
+              <a:rPr sz="1700" b="0">
+                <a:solidFill>
+                  <a:srgbClr val="F2F4F8"/>
+                </a:solidFill>
+                <a:latin typeface="Calibri"/>
+              </a:rPr>
+              <a:t>Influence ledger prevents over-claiming and BU disputes</a:t>
+            </a:r>
+          </a:p>
+        </p:txBody>
+      </p:sp>
+      <p:sp>
+        <p:nvSpPr>
+          <p:cNvPr id="8" name="TextBox 7"/>
+          <p:cNvSpPr txBox="1"/>
+          <p:nvPr/>
+        </p:nvSpPr>
+        <p:spPr>
+          <a:xfrm>
+            <a:off x="548640" y="6419088"/>
+            <a:ext cx="11064240" cy="320040"/>
+          </a:xfrm>
+          <a:prstGeom prst="rect">
+            <a:avLst/>
+          </a:prstGeom>
+          <a:noFill/>
+        </p:spPr>
+        <p:txBody>
+          <a:bodyPr wrap="square" anchor="t">
+            <a:spAutoFit/>
+          </a:bodyPr>
+          <a:lstStyle/>
+          <a:p>
+            <a:pPr algn="l">
+              <a:spcAft>
+                <a:spcPts val="600"/>
+              </a:spcAft>
+            </a:pPr>
+            <a:r>
+              <a:rPr sz="1000" b="0">
+                <a:solidFill>
+                  <a:srgbClr val="9AA3B2"/>
+                </a:solidFill>
+                <a:latin typeface="Calibri"/>
+              </a:rPr>
+              <a:t>Illustrative figures — replace with actuals before presenting.</a:t>
             </a:r>
           </a:p>
         </p:txBody>
@@ -7960,7 +8377,7 @@
                 </a:solidFill>
                 <a:latin typeface="Calibri"/>
               </a:rPr>
-              <a:t>APPENDIX · A1</a:t>
+              <a:t>RECOMMENDATION</a:t>
             </a:r>
           </a:p>
         </p:txBody>
@@ -8042,7 +8459,7 @@
                 </a:solidFill>
                 <a:latin typeface="Calibri"/>
               </a:rPr>
-              <a:t>Role, competencies, and skills matrix</a:t>
+              <a:t>Approve the pilot; first executive framings within 90 days</a:t>
             </a:r>
           </a:p>
         </p:txBody>
@@ -8135,7 +8552,7 @@
                 </a:solidFill>
                 <a:latin typeface="Calibri"/>
               </a:rPr>
-              <a:t>Four competency pillars: business fluency, X-arch depth, exec presence, orchestration</a:t>
+              <a:t>Approve the 12-person, 4-quarter funded pilot with a Q3 gate</a:t>
             </a:r>
           </a:p>
           <a:p>
@@ -8160,7 +8577,7 @@
                 </a:solidFill>
                 <a:latin typeface="Calibri"/>
               </a:rPr>
-              <a:t>Proficiency targets per domain; deep in ≥2 pillars, conversant in all</a:t>
+              <a:t>+30d: group lead named; charter, comp, metrics baselined</a:t>
             </a:r>
           </a:p>
           <a:p>
@@ -8185,7 +8602,32 @@
                 </a:solidFill>
                 <a:latin typeface="Calibri"/>
               </a:rPr>
-              <a:t>Deep in one vertical; team covers all four at expert level</a:t>
+              <a:t>+60d: cohort staffed (internal-first); accounts + controls selected</a:t>
+            </a:r>
+          </a:p>
+          <a:p>
+            <a:pPr algn="l">
+              <a:spcAft>
+                <a:spcPts val="1000"/>
+              </a:spcAft>
+            </a:pPr>
+            <a:r>
+              <a:rPr sz="1700" b="1">
+                <a:solidFill>
+                  <a:srgbClr val="00BCEB"/>
+                </a:solidFill>
+                <a:latin typeface="Calibri"/>
+              </a:rPr>
+              <a:t>•  </a:t>
+            </a:r>
+            <a:r>
+              <a:rPr sz="1700" b="0">
+                <a:solidFill>
+                  <a:srgbClr val="F2F4F8"/>
+                </a:solidFill>
+                <a:latin typeface="Calibri"/>
+              </a:rPr>
+              <a:t>+90d: first X-Arch opportunities framed; enablement ramp underway</a:t>
             </a:r>
           </a:p>
         </p:txBody>
@@ -8224,7 +8666,7 @@
                 </a:solidFill>
                 <a:latin typeface="Calibri"/>
               </a:rPr>
-              <a:t>Appendix — reserve for Q&amp;A. Illustrative figures.</a:t>
+              <a:t>Illustrative figures — replace with actuals before presenting.</a:t>
             </a:r>
           </a:p>
         </p:txBody>
@@ -8299,8 +8741,8 @@
         </p:nvSpPr>
         <p:spPr>
           <a:xfrm>
-            <a:off x="548640" y="411480"/>
-            <a:ext cx="11064240" cy="365760"/>
+            <a:off x="731520" y="2743200"/>
+            <a:ext cx="10698480" cy="914400"/>
           </a:xfrm>
           <a:prstGeom prst="rect">
             <a:avLst/>
@@ -8319,70 +8761,27 @@
               </a:spcAft>
             </a:pPr>
             <a:r>
-              <a:rPr sz="1200" b="1">
+              <a:rPr sz="1600" b="1">
                 <a:solidFill>
                   <a:srgbClr val="00BCEB"/>
                 </a:solidFill>
                 <a:latin typeface="Calibri"/>
               </a:rPr>
-              <a:t>APPENDIX · A2</a:t>
-            </a:r>
-          </a:p>
-        </p:txBody>
-      </p:sp>
-      <p:sp>
-        <p:nvSpPr>
-          <p:cNvPr id="4" name="Rectangle 3"/>
-          <p:cNvSpPr/>
-          <p:nvPr/>
-        </p:nvSpPr>
-        <p:spPr>
-          <a:xfrm>
-            <a:off x="548640" y="868680"/>
-            <a:ext cx="1280160" cy="50800"/>
-          </a:xfrm>
-          <a:prstGeom prst="rect">
-            <a:avLst/>
-          </a:prstGeom>
-          <a:solidFill>
-            <a:srgbClr val="00BCEB"/>
-          </a:solidFill>
-          <a:ln>
-            <a:noFill/>
-          </a:ln>
-        </p:spPr>
-        <p:style>
-          <a:lnRef idx="1">
-            <a:schemeClr val="accent1"/>
-          </a:lnRef>
-          <a:fillRef idx="3">
-            <a:schemeClr val="accent1"/>
-          </a:fillRef>
-          <a:effectRef idx="2">
-            <a:schemeClr val="accent1"/>
-          </a:effectRef>
-          <a:fontRef idx="minor">
-            <a:schemeClr val="lt1"/>
-          </a:fontRef>
-        </p:style>
-        <p:txBody>
-          <a:bodyPr rtlCol="0" anchor="ctr"/>
-          <a:lstStyle/>
-          <a:p>
-            <a:pPr algn="ctr"/>
-          </a:p>
-        </p:txBody>
-      </p:sp>
-      <p:sp>
-        <p:nvSpPr>
-          <p:cNvPr id="5" name="TextBox 4"/>
+              <a:t>APPENDIX</a:t>
+            </a:r>
+          </a:p>
+        </p:txBody>
+      </p:sp>
+      <p:sp>
+        <p:nvSpPr>
+          <p:cNvPr id="4" name="TextBox 3"/>
           <p:cNvSpPr txBox="1"/>
           <p:nvPr/>
         </p:nvSpPr>
         <p:spPr>
           <a:xfrm>
-            <a:off x="548640" y="1051560"/>
-            <a:ext cx="11064240" cy="1005840"/>
+            <a:off x="731520" y="3200400"/>
+            <a:ext cx="10698480" cy="914400"/>
           </a:xfrm>
           <a:prstGeom prst="rect">
             <a:avLst/>
@@ -8401,195 +8800,13 @@
               </a:spcAft>
             </a:pPr>
             <a:r>
-              <a:rPr sz="2800" b="1">
+              <a:rPr sz="3000" b="1">
                 <a:solidFill>
                   <a:srgbClr val="F2F4F8"/>
                 </a:solidFill>
                 <a:latin typeface="Calibri"/>
               </a:rPr>
-              <a:t>Org placement and RACI</a:t>
-            </a:r>
-          </a:p>
-        </p:txBody>
-      </p:sp>
-      <p:sp>
-        <p:nvSpPr>
-          <p:cNvPr id="6" name="Rectangle 5"/>
-          <p:cNvSpPr/>
-          <p:nvPr/>
-        </p:nvSpPr>
-        <p:spPr>
-          <a:xfrm>
-            <a:off x="548640" y="2331720"/>
-            <a:ext cx="11064240" cy="3931920"/>
-          </a:xfrm>
-          <a:prstGeom prst="rect">
-            <a:avLst/>
-          </a:prstGeom>
-          <a:solidFill>
-            <a:srgbClr val="1A1A2E"/>
-          </a:solidFill>
-          <a:ln w="12700">
-            <a:solidFill>
-              <a:srgbClr val="2C2C3A"/>
-            </a:solidFill>
-          </a:ln>
-        </p:spPr>
-        <p:style>
-          <a:lnRef idx="1">
-            <a:schemeClr val="accent1"/>
-          </a:lnRef>
-          <a:fillRef idx="3">
-            <a:schemeClr val="accent1"/>
-          </a:fillRef>
-          <a:effectRef idx="2">
-            <a:schemeClr val="accent1"/>
-          </a:effectRef>
-          <a:fontRef idx="minor">
-            <a:schemeClr val="lt1"/>
-          </a:fontRef>
-        </p:style>
-        <p:txBody>
-          <a:bodyPr rtlCol="0" anchor="ctr"/>
-          <a:lstStyle/>
-          <a:p>
-            <a:pPr algn="ctr"/>
-          </a:p>
-        </p:txBody>
-      </p:sp>
-      <p:sp>
-        <p:nvSpPr>
-          <p:cNvPr id="7" name="TextBox 6"/>
-          <p:cNvSpPr txBox="1"/>
-          <p:nvPr/>
-        </p:nvSpPr>
-        <p:spPr>
-          <a:xfrm>
-            <a:off x="914400" y="2560320"/>
-            <a:ext cx="10332720" cy="3566160"/>
-          </a:xfrm>
-          <a:prstGeom prst="rect">
-            <a:avLst/>
-          </a:prstGeom>
-          <a:noFill/>
-        </p:spPr>
-        <p:txBody>
-          <a:bodyPr wrap="square" anchor="t">
-            <a:spAutoFit/>
-          </a:bodyPr>
-          <a:lstStyle/>
-          <a:p>
-            <a:pPr algn="l">
-              <a:spcAft>
-                <a:spcPts val="1000"/>
-              </a:spcAft>
-            </a:pPr>
-            <a:r>
-              <a:rPr sz="1700" b="1">
-                <a:solidFill>
-                  <a:srgbClr val="00BCEB"/>
-                </a:solidFill>
-                <a:latin typeface="Calibri"/>
-              </a:rPr>
-              <a:t>•  </a:t>
-            </a:r>
-            <a:r>
-              <a:rPr sz="1700" b="0">
-                <a:solidFill>
-                  <a:srgbClr val="F2F4F8"/>
-                </a:solidFill>
-                <a:latin typeface="Calibri"/>
-              </a:rPr>
-              <a:t>GTM-primary reporting with a strong dotted line to the CTO/engineering org</a:t>
-            </a:r>
-          </a:p>
-          <a:p>
-            <a:pPr algn="l">
-              <a:spcAft>
-                <a:spcPts val="1000"/>
-              </a:spcAft>
-            </a:pPr>
-            <a:r>
-              <a:rPr sz="1700" b="1">
-                <a:solidFill>
-                  <a:srgbClr val="00BCEB"/>
-                </a:solidFill>
-                <a:latin typeface="Calibri"/>
-              </a:rPr>
-              <a:t>•  </a:t>
-            </a:r>
-            <a:r>
-              <a:rPr sz="1700" b="0">
-                <a:solidFill>
-                  <a:srgbClr val="F2F4F8"/>
-                </a:solidFill>
-                <a:latin typeface="Calibri"/>
-              </a:rPr>
-              <a:t>Keeps it revenue-accountable AND cross-BU neutral</a:t>
-            </a:r>
-          </a:p>
-          <a:p>
-            <a:pPr algn="l">
-              <a:spcAft>
-                <a:spcPts val="1000"/>
-              </a:spcAft>
-            </a:pPr>
-            <a:r>
-              <a:rPr sz="1700" b="1">
-                <a:solidFill>
-                  <a:srgbClr val="00BCEB"/>
-                </a:solidFill>
-                <a:latin typeface="Calibri"/>
-              </a:rPr>
-              <a:t>•  </a:t>
-            </a:r>
-            <a:r>
-              <a:rPr sz="1700" b="0">
-                <a:solidFill>
-                  <a:srgbClr val="F2F4F8"/>
-                </a:solidFill>
-                <a:latin typeface="Calibri"/>
-              </a:rPr>
-              <a:t>RACI: Field CTO accountable for the frame; AE accountable for the account</a:t>
-            </a:r>
-          </a:p>
-        </p:txBody>
-      </p:sp>
-      <p:sp>
-        <p:nvSpPr>
-          <p:cNvPr id="8" name="TextBox 7"/>
-          <p:cNvSpPr txBox="1"/>
-          <p:nvPr/>
-        </p:nvSpPr>
-        <p:spPr>
-          <a:xfrm>
-            <a:off x="548640" y="6419088"/>
-            <a:ext cx="11064240" cy="320040"/>
-          </a:xfrm>
-          <a:prstGeom prst="rect">
-            <a:avLst/>
-          </a:prstGeom>
-          <a:noFill/>
-        </p:spPr>
-        <p:txBody>
-          <a:bodyPr wrap="square" anchor="t">
-            <a:spAutoFit/>
-          </a:bodyPr>
-          <a:lstStyle/>
-          <a:p>
-            <a:pPr algn="l">
-              <a:spcAft>
-                <a:spcPts val="600"/>
-              </a:spcAft>
-            </a:pPr>
-            <a:r>
-              <a:rPr sz="1000" b="0">
-                <a:solidFill>
-                  <a:srgbClr val="9AA3B2"/>
-                </a:solidFill>
-                <a:latin typeface="Calibri"/>
-              </a:rPr>
-              <a:t>Appendix — reserve for Q&amp;A. Illustrative figures.</a:t>
+              <a:t>Detail held in reserve for Q&amp;A</a:t>
             </a:r>
           </a:p>
         </p:txBody>
@@ -8690,7 +8907,7 @@
                 </a:solidFill>
                 <a:latin typeface="Calibri"/>
               </a:rPr>
-              <a:t>APPENDIX · A3</a:t>
+              <a:t>APPENDIX · A1</a:t>
             </a:r>
           </a:p>
         </p:txBody>
@@ -8772,7 +8989,7 @@
                 </a:solidFill>
                 <a:latin typeface="Calibri"/>
               </a:rPr>
-              <a:t>Per-vertical field engagement kits</a:t>
+              <a:t>Role, competencies, and skills matrix</a:t>
             </a:r>
           </a:p>
         </p:txBody>
@@ -8865,7 +9082,7 @@
                 </a:solidFill>
                 <a:latin typeface="Calibri"/>
               </a:rPr>
-              <a:t>Buyers, discovery questions, outcome hypotheses, objection handling</a:t>
+              <a:t>Four competency pillars: business fluency, X-arch depth, exec presence, orchestration</a:t>
             </a:r>
           </a:p>
           <a:p>
@@ -8890,7 +9107,7 @@
                 </a:solidFill>
                 <a:latin typeface="Calibri"/>
               </a:rPr>
-              <a:t>One kit per vertical: Transportation, FinServ, Healthcare, Public Sector</a:t>
+              <a:t>Proficiency targets per domain; deep in ≥2 pillars, conversant in all</a:t>
             </a:r>
           </a:p>
           <a:p>
@@ -8915,7 +9132,7 @@
                 </a:solidFill>
                 <a:latin typeface="Calibri"/>
               </a:rPr>
-              <a:t>Turns the strategy into a field-ready playbook</a:t>
+              <a:t>Deep in one vertical; team covers all four at expert level</a:t>
             </a:r>
           </a:p>
         </p:txBody>
@@ -9445,7 +9662,7 @@
                 </a:solidFill>
                 <a:latin typeface="Calibri"/>
               </a:rPr>
-              <a:t>APPENDIX · A4</a:t>
+              <a:t>APPENDIX · A2</a:t>
             </a:r>
           </a:p>
         </p:txBody>
@@ -9527,7 +9744,7 @@
                 </a:solidFill>
                 <a:latin typeface="Calibri"/>
               </a:rPr>
-              <a:t>OT safety boundary</a:t>
+              <a:t>Org placement and RACI</a:t>
             </a:r>
           </a:p>
         </p:txBody>
@@ -9620,7 +9837,7 @@
                 </a:solidFill>
                 <a:latin typeface="Calibri"/>
               </a:rPr>
-              <a:t>Read-only / passive acquisition for safety-related signals</a:t>
+              <a:t>GTM-primary reporting with a strong dotted line to the CTO/engineering org</a:t>
             </a:r>
           </a:p>
           <a:p>
@@ -9645,7 +9862,7 @@
                 </a:solidFill>
                 <a:latin typeface="Calibri"/>
               </a:rPr>
-              <a:t>Never write config to PLCs/HMIs/DCS/RTUs/SIS; human-in-the-loop response</a:t>
+              <a:t>Keeps it revenue-accountable AND cross-BU neutral</a:t>
             </a:r>
           </a:p>
           <a:p>
@@ -9670,7 +9887,7 @@
                 </a:solidFill>
                 <a:latin typeface="Calibri"/>
               </a:rPr>
-              <a:t>A hard guardrail AND a competitive differentiator that earns OT trust</a:t>
+              <a:t>RACI: Field CTO accountable for the frame; AE accountable for the account</a:t>
             </a:r>
           </a:p>
         </p:txBody>
@@ -9810,7 +10027,7 @@
                 </a:solidFill>
                 <a:latin typeface="Calibri"/>
               </a:rPr>
-              <a:t>APPENDIX · A5</a:t>
+              <a:t>APPENDIX · A3</a:t>
             </a:r>
           </a:p>
         </p:txBody>
@@ -9892,7 +10109,7 @@
                 </a:solidFill>
                 <a:latin typeface="Calibri"/>
               </a:rPr>
-              <a:t>Assumptions register and 3-year P&amp;L</a:t>
+              <a:t>Per-vertical field engagement kits</a:t>
             </a:r>
           </a:p>
         </p:txBody>
@@ -9985,7 +10202,7 @@
                 </a:solidFill>
                 <a:latin typeface="Calibri"/>
               </a:rPr>
-              <a:t>Every financial input (A1–A13) is visible and editable</a:t>
+              <a:t>Buyers, discovery questions, outcome hypotheses, objection handling</a:t>
             </a:r>
           </a:p>
           <a:p>
@@ -10010,7 +10227,7 @@
                 </a:solidFill>
                 <a:latin typeface="Calibri"/>
               </a:rPr>
-              <a:t>3-year scale path with improving ROI multiple</a:t>
+              <a:t>One kit per vertical: Transportation, FinServ, Healthcare, Public Sector</a:t>
             </a:r>
           </a:p>
           <a:p>
@@ -10035,7 +10252,7 @@
                 </a:solidFill>
                 <a:latin typeface="Calibri"/>
               </a:rPr>
-              <a:t>Structure holds; only inputs change when actuals are plugged in</a:t>
+              <a:t>Turns the strategy into a field-ready playbook</a:t>
             </a:r>
           </a:p>
         </p:txBody>
@@ -10175,7 +10392,7 @@
                 </a:solidFill>
                 <a:latin typeface="Calibri"/>
               </a:rPr>
-              <a:t>APPENDIX · A6</a:t>
+              <a:t>APPENDIX · A4</a:t>
             </a:r>
           </a:p>
         </p:txBody>
@@ -10257,7 +10474,7 @@
                 </a:solidFill>
                 <a:latin typeface="Calibri"/>
               </a:rPr>
-              <a:t>Compensation design</a:t>
+              <a:t>OT safety boundary</a:t>
             </a:r>
           </a:p>
         </p:txBody>
@@ -10350,7 +10567,7 @@
                 </a:solidFill>
                 <a:latin typeface="Calibri"/>
               </a:rPr>
-              <a:t>Influence credit is additive — BU sellers keep 100% of product credit</a:t>
+              <a:t>Read-only / passive acquisition for safety-related signals</a:t>
             </a:r>
           </a:p>
           <a:p>
@@ -10375,7 +10592,7 @@
                 </a:solidFill>
                 <a:latin typeface="Calibri"/>
               </a:rPr>
-              <a:t>Weighting: 50% influenced bookings, 20% Splunk attach, 15% leading, 15% MBOs</a:t>
+              <a:t>Never write config to PLCs/HMIs/DCS/RTUs/SIS; human-in-the-loop response</a:t>
             </a:r>
           </a:p>
           <a:p>
@@ -10400,7 +10617,7 @@
                 </a:solidFill>
                 <a:latin typeface="Calibri"/>
               </a:rPr>
-              <a:t>Deal desk arbitrates via the influence ledger</a:t>
+              <a:t>A hard guardrail AND a competitive differentiator that earns OT trust</a:t>
             </a:r>
           </a:p>
         </p:txBody>
@@ -10540,7 +10757,7 @@
                 </a:solidFill>
                 <a:latin typeface="Calibri"/>
               </a:rPr>
-              <a:t>APPENDIX · A7</a:t>
+              <a:t>APPENDIX · A5</a:t>
             </a:r>
           </a:p>
         </p:txBody>
@@ -10622,7 +10839,7 @@
                 </a:solidFill>
                 <a:latin typeface="Calibri"/>
               </a:rPr>
-              <a:t>Competitive framing</a:t>
+              <a:t>Assumptions register and 3-year P&amp;L</a:t>
             </a:r>
           </a:p>
         </p:txBody>
@@ -10715,7 +10932,7 @@
                 </a:solidFill>
                 <a:latin typeface="Calibri"/>
               </a:rPr>
-              <a:t>Point vendors, SIEM/observability specialists, SIs, hyperscalers</a:t>
+              <a:t>Every financial input (A1–A13) is visible and editable</a:t>
             </a:r>
           </a:p>
           <a:p>
@@ -10740,7 +10957,7 @@
                 </a:solidFill>
                 <a:latin typeface="Calibri"/>
               </a:rPr>
-              <a:t>The SI dynamic is the biggest structural risk — co-author the architecture</a:t>
+              <a:t>3-year scale path with improving ROI multiple</a:t>
             </a:r>
           </a:p>
           <a:p>
@@ -10765,7 +10982,7 @@
                 </a:solidFill>
                 <a:latin typeface="Calibri"/>
               </a:rPr>
-              <a:t>Whoever frames the architecture wins the budget</a:t>
+              <a:t>Structure holds; only inputs change when actuals are plugged in</a:t>
             </a:r>
           </a:p>
         </p:txBody>
@@ -10905,6 +11122,736 @@
                 </a:solidFill>
                 <a:latin typeface="Calibri"/>
               </a:rPr>
+              <a:t>APPENDIX · A6</a:t>
+            </a:r>
+          </a:p>
+        </p:txBody>
+      </p:sp>
+      <p:sp>
+        <p:nvSpPr>
+          <p:cNvPr id="4" name="Rectangle 3"/>
+          <p:cNvSpPr/>
+          <p:nvPr/>
+        </p:nvSpPr>
+        <p:spPr>
+          <a:xfrm>
+            <a:off x="548640" y="868680"/>
+            <a:ext cx="1280160" cy="50800"/>
+          </a:xfrm>
+          <a:prstGeom prst="rect">
+            <a:avLst/>
+          </a:prstGeom>
+          <a:solidFill>
+            <a:srgbClr val="00BCEB"/>
+          </a:solidFill>
+          <a:ln>
+            <a:noFill/>
+          </a:ln>
+        </p:spPr>
+        <p:style>
+          <a:lnRef idx="1">
+            <a:schemeClr val="accent1"/>
+          </a:lnRef>
+          <a:fillRef idx="3">
+            <a:schemeClr val="accent1"/>
+          </a:fillRef>
+          <a:effectRef idx="2">
+            <a:schemeClr val="accent1"/>
+          </a:effectRef>
+          <a:fontRef idx="minor">
+            <a:schemeClr val="lt1"/>
+          </a:fontRef>
+        </p:style>
+        <p:txBody>
+          <a:bodyPr rtlCol="0" anchor="ctr"/>
+          <a:lstStyle/>
+          <a:p>
+            <a:pPr algn="ctr"/>
+          </a:p>
+        </p:txBody>
+      </p:sp>
+      <p:sp>
+        <p:nvSpPr>
+          <p:cNvPr id="5" name="TextBox 4"/>
+          <p:cNvSpPr txBox="1"/>
+          <p:nvPr/>
+        </p:nvSpPr>
+        <p:spPr>
+          <a:xfrm>
+            <a:off x="548640" y="1051560"/>
+            <a:ext cx="11064240" cy="1005840"/>
+          </a:xfrm>
+          <a:prstGeom prst="rect">
+            <a:avLst/>
+          </a:prstGeom>
+          <a:noFill/>
+        </p:spPr>
+        <p:txBody>
+          <a:bodyPr wrap="square" anchor="t">
+            <a:spAutoFit/>
+          </a:bodyPr>
+          <a:lstStyle/>
+          <a:p>
+            <a:pPr algn="l">
+              <a:spcAft>
+                <a:spcPts val="600"/>
+              </a:spcAft>
+            </a:pPr>
+            <a:r>
+              <a:rPr sz="2800" b="1">
+                <a:solidFill>
+                  <a:srgbClr val="F2F4F8"/>
+                </a:solidFill>
+                <a:latin typeface="Calibri"/>
+              </a:rPr>
+              <a:t>Compensation design</a:t>
+            </a:r>
+          </a:p>
+        </p:txBody>
+      </p:sp>
+      <p:sp>
+        <p:nvSpPr>
+          <p:cNvPr id="6" name="Rectangle 5"/>
+          <p:cNvSpPr/>
+          <p:nvPr/>
+        </p:nvSpPr>
+        <p:spPr>
+          <a:xfrm>
+            <a:off x="548640" y="2331720"/>
+            <a:ext cx="11064240" cy="3931920"/>
+          </a:xfrm>
+          <a:prstGeom prst="rect">
+            <a:avLst/>
+          </a:prstGeom>
+          <a:solidFill>
+            <a:srgbClr val="1A1A2E"/>
+          </a:solidFill>
+          <a:ln w="12700">
+            <a:solidFill>
+              <a:srgbClr val="2C2C3A"/>
+            </a:solidFill>
+          </a:ln>
+        </p:spPr>
+        <p:style>
+          <a:lnRef idx="1">
+            <a:schemeClr val="accent1"/>
+          </a:lnRef>
+          <a:fillRef idx="3">
+            <a:schemeClr val="accent1"/>
+          </a:fillRef>
+          <a:effectRef idx="2">
+            <a:schemeClr val="accent1"/>
+          </a:effectRef>
+          <a:fontRef idx="minor">
+            <a:schemeClr val="lt1"/>
+          </a:fontRef>
+        </p:style>
+        <p:txBody>
+          <a:bodyPr rtlCol="0" anchor="ctr"/>
+          <a:lstStyle/>
+          <a:p>
+            <a:pPr algn="ctr"/>
+          </a:p>
+        </p:txBody>
+      </p:sp>
+      <p:sp>
+        <p:nvSpPr>
+          <p:cNvPr id="7" name="TextBox 6"/>
+          <p:cNvSpPr txBox="1"/>
+          <p:nvPr/>
+        </p:nvSpPr>
+        <p:spPr>
+          <a:xfrm>
+            <a:off x="914400" y="2560320"/>
+            <a:ext cx="10332720" cy="3566160"/>
+          </a:xfrm>
+          <a:prstGeom prst="rect">
+            <a:avLst/>
+          </a:prstGeom>
+          <a:noFill/>
+        </p:spPr>
+        <p:txBody>
+          <a:bodyPr wrap="square" anchor="t">
+            <a:spAutoFit/>
+          </a:bodyPr>
+          <a:lstStyle/>
+          <a:p>
+            <a:pPr algn="l">
+              <a:spcAft>
+                <a:spcPts val="1000"/>
+              </a:spcAft>
+            </a:pPr>
+            <a:r>
+              <a:rPr sz="1700" b="1">
+                <a:solidFill>
+                  <a:srgbClr val="00BCEB"/>
+                </a:solidFill>
+                <a:latin typeface="Calibri"/>
+              </a:rPr>
+              <a:t>•  </a:t>
+            </a:r>
+            <a:r>
+              <a:rPr sz="1700" b="0">
+                <a:solidFill>
+                  <a:srgbClr val="F2F4F8"/>
+                </a:solidFill>
+                <a:latin typeface="Calibri"/>
+              </a:rPr>
+              <a:t>Influence credit is additive — BU sellers keep 100% of product credit</a:t>
+            </a:r>
+          </a:p>
+          <a:p>
+            <a:pPr algn="l">
+              <a:spcAft>
+                <a:spcPts val="1000"/>
+              </a:spcAft>
+            </a:pPr>
+            <a:r>
+              <a:rPr sz="1700" b="1">
+                <a:solidFill>
+                  <a:srgbClr val="00BCEB"/>
+                </a:solidFill>
+                <a:latin typeface="Calibri"/>
+              </a:rPr>
+              <a:t>•  </a:t>
+            </a:r>
+            <a:r>
+              <a:rPr sz="1700" b="0">
+                <a:solidFill>
+                  <a:srgbClr val="F2F4F8"/>
+                </a:solidFill>
+                <a:latin typeface="Calibri"/>
+              </a:rPr>
+              <a:t>Weighting: 50% influenced bookings, 20% Splunk attach, 15% leading, 15% MBOs</a:t>
+            </a:r>
+          </a:p>
+          <a:p>
+            <a:pPr algn="l">
+              <a:spcAft>
+                <a:spcPts val="1000"/>
+              </a:spcAft>
+            </a:pPr>
+            <a:r>
+              <a:rPr sz="1700" b="1">
+                <a:solidFill>
+                  <a:srgbClr val="00BCEB"/>
+                </a:solidFill>
+                <a:latin typeface="Calibri"/>
+              </a:rPr>
+              <a:t>•  </a:t>
+            </a:r>
+            <a:r>
+              <a:rPr sz="1700" b="0">
+                <a:solidFill>
+                  <a:srgbClr val="F2F4F8"/>
+                </a:solidFill>
+                <a:latin typeface="Calibri"/>
+              </a:rPr>
+              <a:t>Deal desk arbitrates via the influence ledger</a:t>
+            </a:r>
+          </a:p>
+        </p:txBody>
+      </p:sp>
+      <p:sp>
+        <p:nvSpPr>
+          <p:cNvPr id="8" name="TextBox 7"/>
+          <p:cNvSpPr txBox="1"/>
+          <p:nvPr/>
+        </p:nvSpPr>
+        <p:spPr>
+          <a:xfrm>
+            <a:off x="548640" y="6419088"/>
+            <a:ext cx="11064240" cy="320040"/>
+          </a:xfrm>
+          <a:prstGeom prst="rect">
+            <a:avLst/>
+          </a:prstGeom>
+          <a:noFill/>
+        </p:spPr>
+        <p:txBody>
+          <a:bodyPr wrap="square" anchor="t">
+            <a:spAutoFit/>
+          </a:bodyPr>
+          <a:lstStyle/>
+          <a:p>
+            <a:pPr algn="l">
+              <a:spcAft>
+                <a:spcPts val="600"/>
+              </a:spcAft>
+            </a:pPr>
+            <a:r>
+              <a:rPr sz="1000" b="0">
+                <a:solidFill>
+                  <a:srgbClr val="9AA3B2"/>
+                </a:solidFill>
+                <a:latin typeface="Calibri"/>
+              </a:rPr>
+              <a:t>Appendix — reserve for Q&amp;A. Illustrative figures.</a:t>
+            </a:r>
+          </a:p>
+        </p:txBody>
+      </p:sp>
+    </p:spTree>
+  </p:cSld>
+  <p:clrMapOvr>
+    <a:masterClrMapping/>
+  </p:clrMapOvr>
+</p:sld>
+</file>
+
+<file path=ppt/slides/slide25.xml><?xml version="1.0" encoding="utf-8"?>
+<p:sld xmlns:a="http://schemas.openxmlformats.org/drawingml/2006/main" xmlns:p="http://schemas.openxmlformats.org/presentationml/2006/main" xmlns:r="http://schemas.openxmlformats.org/officeDocument/2006/relationships">
+  <p:cSld>
+    <p:spTree>
+      <p:nvGrpSpPr>
+        <p:cNvPr id="1" name=""/>
+        <p:cNvGrpSpPr/>
+        <p:nvPr/>
+      </p:nvGrpSpPr>
+      <p:grpSpPr/>
+      <p:sp>
+        <p:nvSpPr>
+          <p:cNvPr id="2" name="Rectangle 1"/>
+          <p:cNvSpPr/>
+          <p:nvPr/>
+        </p:nvSpPr>
+        <p:spPr>
+          <a:xfrm>
+            <a:off x="0" y="0"/>
+            <a:ext cx="12191695" cy="6858000"/>
+          </a:xfrm>
+          <a:prstGeom prst="rect">
+            <a:avLst/>
+          </a:prstGeom>
+          <a:solidFill>
+            <a:srgbClr val="101014"/>
+          </a:solidFill>
+          <a:ln>
+            <a:noFill/>
+          </a:ln>
+          <a:effectLst/>
+        </p:spPr>
+        <p:style>
+          <a:lnRef idx="1">
+            <a:schemeClr val="accent1"/>
+          </a:lnRef>
+          <a:fillRef idx="3">
+            <a:schemeClr val="accent1"/>
+          </a:fillRef>
+          <a:effectRef idx="2">
+            <a:schemeClr val="accent1"/>
+          </a:effectRef>
+          <a:fontRef idx="minor">
+            <a:schemeClr val="lt1"/>
+          </a:fontRef>
+        </p:style>
+        <p:txBody>
+          <a:bodyPr rtlCol="0" anchor="ctr"/>
+          <a:lstStyle/>
+          <a:p>
+            <a:pPr algn="ctr"/>
+          </a:p>
+        </p:txBody>
+      </p:sp>
+      <p:sp>
+        <p:nvSpPr>
+          <p:cNvPr id="3" name="TextBox 2"/>
+          <p:cNvSpPr txBox="1"/>
+          <p:nvPr/>
+        </p:nvSpPr>
+        <p:spPr>
+          <a:xfrm>
+            <a:off x="548640" y="411480"/>
+            <a:ext cx="11064240" cy="365760"/>
+          </a:xfrm>
+          <a:prstGeom prst="rect">
+            <a:avLst/>
+          </a:prstGeom>
+          <a:noFill/>
+        </p:spPr>
+        <p:txBody>
+          <a:bodyPr wrap="square" anchor="t">
+            <a:spAutoFit/>
+          </a:bodyPr>
+          <a:lstStyle/>
+          <a:p>
+            <a:pPr algn="l">
+              <a:spcAft>
+                <a:spcPts val="600"/>
+              </a:spcAft>
+            </a:pPr>
+            <a:r>
+              <a:rPr sz="1200" b="1">
+                <a:solidFill>
+                  <a:srgbClr val="00BCEB"/>
+                </a:solidFill>
+                <a:latin typeface="Calibri"/>
+              </a:rPr>
+              <a:t>APPENDIX · A7</a:t>
+            </a:r>
+          </a:p>
+        </p:txBody>
+      </p:sp>
+      <p:sp>
+        <p:nvSpPr>
+          <p:cNvPr id="4" name="Rectangle 3"/>
+          <p:cNvSpPr/>
+          <p:nvPr/>
+        </p:nvSpPr>
+        <p:spPr>
+          <a:xfrm>
+            <a:off x="548640" y="868680"/>
+            <a:ext cx="1280160" cy="50800"/>
+          </a:xfrm>
+          <a:prstGeom prst="rect">
+            <a:avLst/>
+          </a:prstGeom>
+          <a:solidFill>
+            <a:srgbClr val="00BCEB"/>
+          </a:solidFill>
+          <a:ln>
+            <a:noFill/>
+          </a:ln>
+        </p:spPr>
+        <p:style>
+          <a:lnRef idx="1">
+            <a:schemeClr val="accent1"/>
+          </a:lnRef>
+          <a:fillRef idx="3">
+            <a:schemeClr val="accent1"/>
+          </a:fillRef>
+          <a:effectRef idx="2">
+            <a:schemeClr val="accent1"/>
+          </a:effectRef>
+          <a:fontRef idx="minor">
+            <a:schemeClr val="lt1"/>
+          </a:fontRef>
+        </p:style>
+        <p:txBody>
+          <a:bodyPr rtlCol="0" anchor="ctr"/>
+          <a:lstStyle/>
+          <a:p>
+            <a:pPr algn="ctr"/>
+          </a:p>
+        </p:txBody>
+      </p:sp>
+      <p:sp>
+        <p:nvSpPr>
+          <p:cNvPr id="5" name="TextBox 4"/>
+          <p:cNvSpPr txBox="1"/>
+          <p:nvPr/>
+        </p:nvSpPr>
+        <p:spPr>
+          <a:xfrm>
+            <a:off x="548640" y="1051560"/>
+            <a:ext cx="11064240" cy="1005840"/>
+          </a:xfrm>
+          <a:prstGeom prst="rect">
+            <a:avLst/>
+          </a:prstGeom>
+          <a:noFill/>
+        </p:spPr>
+        <p:txBody>
+          <a:bodyPr wrap="square" anchor="t">
+            <a:spAutoFit/>
+          </a:bodyPr>
+          <a:lstStyle/>
+          <a:p>
+            <a:pPr algn="l">
+              <a:spcAft>
+                <a:spcPts val="600"/>
+              </a:spcAft>
+            </a:pPr>
+            <a:r>
+              <a:rPr sz="2800" b="1">
+                <a:solidFill>
+                  <a:srgbClr val="F2F4F8"/>
+                </a:solidFill>
+                <a:latin typeface="Calibri"/>
+              </a:rPr>
+              <a:t>Competitive framing</a:t>
+            </a:r>
+          </a:p>
+        </p:txBody>
+      </p:sp>
+      <p:sp>
+        <p:nvSpPr>
+          <p:cNvPr id="6" name="Rectangle 5"/>
+          <p:cNvSpPr/>
+          <p:nvPr/>
+        </p:nvSpPr>
+        <p:spPr>
+          <a:xfrm>
+            <a:off x="548640" y="2331720"/>
+            <a:ext cx="11064240" cy="3931920"/>
+          </a:xfrm>
+          <a:prstGeom prst="rect">
+            <a:avLst/>
+          </a:prstGeom>
+          <a:solidFill>
+            <a:srgbClr val="1A1A2E"/>
+          </a:solidFill>
+          <a:ln w="12700">
+            <a:solidFill>
+              <a:srgbClr val="2C2C3A"/>
+            </a:solidFill>
+          </a:ln>
+        </p:spPr>
+        <p:style>
+          <a:lnRef idx="1">
+            <a:schemeClr val="accent1"/>
+          </a:lnRef>
+          <a:fillRef idx="3">
+            <a:schemeClr val="accent1"/>
+          </a:fillRef>
+          <a:effectRef idx="2">
+            <a:schemeClr val="accent1"/>
+          </a:effectRef>
+          <a:fontRef idx="minor">
+            <a:schemeClr val="lt1"/>
+          </a:fontRef>
+        </p:style>
+        <p:txBody>
+          <a:bodyPr rtlCol="0" anchor="ctr"/>
+          <a:lstStyle/>
+          <a:p>
+            <a:pPr algn="ctr"/>
+          </a:p>
+        </p:txBody>
+      </p:sp>
+      <p:sp>
+        <p:nvSpPr>
+          <p:cNvPr id="7" name="TextBox 6"/>
+          <p:cNvSpPr txBox="1"/>
+          <p:nvPr/>
+        </p:nvSpPr>
+        <p:spPr>
+          <a:xfrm>
+            <a:off x="914400" y="2560320"/>
+            <a:ext cx="10332720" cy="3566160"/>
+          </a:xfrm>
+          <a:prstGeom prst="rect">
+            <a:avLst/>
+          </a:prstGeom>
+          <a:noFill/>
+        </p:spPr>
+        <p:txBody>
+          <a:bodyPr wrap="square" anchor="t">
+            <a:spAutoFit/>
+          </a:bodyPr>
+          <a:lstStyle/>
+          <a:p>
+            <a:pPr algn="l">
+              <a:spcAft>
+                <a:spcPts val="1000"/>
+              </a:spcAft>
+            </a:pPr>
+            <a:r>
+              <a:rPr sz="1700" b="1">
+                <a:solidFill>
+                  <a:srgbClr val="00BCEB"/>
+                </a:solidFill>
+                <a:latin typeface="Calibri"/>
+              </a:rPr>
+              <a:t>•  </a:t>
+            </a:r>
+            <a:r>
+              <a:rPr sz="1700" b="0">
+                <a:solidFill>
+                  <a:srgbClr val="F2F4F8"/>
+                </a:solidFill>
+                <a:latin typeface="Calibri"/>
+              </a:rPr>
+              <a:t>Point vendors, SIEM/observability specialists, SIs, hyperscalers</a:t>
+            </a:r>
+          </a:p>
+          <a:p>
+            <a:pPr algn="l">
+              <a:spcAft>
+                <a:spcPts val="1000"/>
+              </a:spcAft>
+            </a:pPr>
+            <a:r>
+              <a:rPr sz="1700" b="1">
+                <a:solidFill>
+                  <a:srgbClr val="00BCEB"/>
+                </a:solidFill>
+                <a:latin typeface="Calibri"/>
+              </a:rPr>
+              <a:t>•  </a:t>
+            </a:r>
+            <a:r>
+              <a:rPr sz="1700" b="0">
+                <a:solidFill>
+                  <a:srgbClr val="F2F4F8"/>
+                </a:solidFill>
+                <a:latin typeface="Calibri"/>
+              </a:rPr>
+              <a:t>The SI dynamic is the biggest structural risk — co-author the architecture</a:t>
+            </a:r>
+          </a:p>
+          <a:p>
+            <a:pPr algn="l">
+              <a:spcAft>
+                <a:spcPts val="1000"/>
+              </a:spcAft>
+            </a:pPr>
+            <a:r>
+              <a:rPr sz="1700" b="1">
+                <a:solidFill>
+                  <a:srgbClr val="00BCEB"/>
+                </a:solidFill>
+                <a:latin typeface="Calibri"/>
+              </a:rPr>
+              <a:t>•  </a:t>
+            </a:r>
+            <a:r>
+              <a:rPr sz="1700" b="0">
+                <a:solidFill>
+                  <a:srgbClr val="F2F4F8"/>
+                </a:solidFill>
+                <a:latin typeface="Calibri"/>
+              </a:rPr>
+              <a:t>Whoever frames the architecture wins the budget</a:t>
+            </a:r>
+          </a:p>
+        </p:txBody>
+      </p:sp>
+      <p:sp>
+        <p:nvSpPr>
+          <p:cNvPr id="8" name="TextBox 7"/>
+          <p:cNvSpPr txBox="1"/>
+          <p:nvPr/>
+        </p:nvSpPr>
+        <p:spPr>
+          <a:xfrm>
+            <a:off x="548640" y="6419088"/>
+            <a:ext cx="11064240" cy="320040"/>
+          </a:xfrm>
+          <a:prstGeom prst="rect">
+            <a:avLst/>
+          </a:prstGeom>
+          <a:noFill/>
+        </p:spPr>
+        <p:txBody>
+          <a:bodyPr wrap="square" anchor="t">
+            <a:spAutoFit/>
+          </a:bodyPr>
+          <a:lstStyle/>
+          <a:p>
+            <a:pPr algn="l">
+              <a:spcAft>
+                <a:spcPts val="600"/>
+              </a:spcAft>
+            </a:pPr>
+            <a:r>
+              <a:rPr sz="1000" b="0">
+                <a:solidFill>
+                  <a:srgbClr val="9AA3B2"/>
+                </a:solidFill>
+                <a:latin typeface="Calibri"/>
+              </a:rPr>
+              <a:t>Appendix — reserve for Q&amp;A. Illustrative figures.</a:t>
+            </a:r>
+          </a:p>
+        </p:txBody>
+      </p:sp>
+    </p:spTree>
+  </p:cSld>
+  <p:clrMapOvr>
+    <a:masterClrMapping/>
+  </p:clrMapOvr>
+</p:sld>
+</file>
+
+<file path=ppt/slides/slide26.xml><?xml version="1.0" encoding="utf-8"?>
+<p:sld xmlns:a="http://schemas.openxmlformats.org/drawingml/2006/main" xmlns:p="http://schemas.openxmlformats.org/presentationml/2006/main" xmlns:r="http://schemas.openxmlformats.org/officeDocument/2006/relationships">
+  <p:cSld>
+    <p:spTree>
+      <p:nvGrpSpPr>
+        <p:cNvPr id="1" name=""/>
+        <p:cNvGrpSpPr/>
+        <p:nvPr/>
+      </p:nvGrpSpPr>
+      <p:grpSpPr/>
+      <p:sp>
+        <p:nvSpPr>
+          <p:cNvPr id="2" name="Rectangle 1"/>
+          <p:cNvSpPr/>
+          <p:nvPr/>
+        </p:nvSpPr>
+        <p:spPr>
+          <a:xfrm>
+            <a:off x="0" y="0"/>
+            <a:ext cx="12191695" cy="6858000"/>
+          </a:xfrm>
+          <a:prstGeom prst="rect">
+            <a:avLst/>
+          </a:prstGeom>
+          <a:solidFill>
+            <a:srgbClr val="101014"/>
+          </a:solidFill>
+          <a:ln>
+            <a:noFill/>
+          </a:ln>
+          <a:effectLst/>
+        </p:spPr>
+        <p:style>
+          <a:lnRef idx="1">
+            <a:schemeClr val="accent1"/>
+          </a:lnRef>
+          <a:fillRef idx="3">
+            <a:schemeClr val="accent1"/>
+          </a:fillRef>
+          <a:effectRef idx="2">
+            <a:schemeClr val="accent1"/>
+          </a:effectRef>
+          <a:fontRef idx="minor">
+            <a:schemeClr val="lt1"/>
+          </a:fontRef>
+        </p:style>
+        <p:txBody>
+          <a:bodyPr rtlCol="0" anchor="ctr"/>
+          <a:lstStyle/>
+          <a:p>
+            <a:pPr algn="ctr"/>
+          </a:p>
+        </p:txBody>
+      </p:sp>
+      <p:sp>
+        <p:nvSpPr>
+          <p:cNvPr id="3" name="TextBox 2"/>
+          <p:cNvSpPr txBox="1"/>
+          <p:nvPr/>
+        </p:nvSpPr>
+        <p:spPr>
+          <a:xfrm>
+            <a:off x="548640" y="411480"/>
+            <a:ext cx="11064240" cy="365760"/>
+          </a:xfrm>
+          <a:prstGeom prst="rect">
+            <a:avLst/>
+          </a:prstGeom>
+          <a:noFill/>
+        </p:spPr>
+        <p:txBody>
+          <a:bodyPr wrap="square" anchor="t">
+            <a:spAutoFit/>
+          </a:bodyPr>
+          <a:lstStyle/>
+          <a:p>
+            <a:pPr algn="l">
+              <a:spcAft>
+                <a:spcPts val="600"/>
+              </a:spcAft>
+            </a:pPr>
+            <a:r>
+              <a:rPr sz="1200" b="1">
+                <a:solidFill>
+                  <a:srgbClr val="00BCEB"/>
+                </a:solidFill>
+                <a:latin typeface="Calibri"/>
+              </a:rPr>
               <a:t>APPENDIX · A8</a:t>
             </a:r>
           </a:p>
@@ -12830,7 +13777,7 @@
                 </a:solidFill>
                 <a:latin typeface="Calibri"/>
               </a:rPr>
-              <a:t>IN PRACTICE</a:t>
+              <a:t>EXTENDING THE MODEL</a:t>
             </a:r>
           </a:p>
         </p:txBody>
@@ -12912,7 +13859,7 @@
                 </a:solidFill>
                 <a:latin typeface="Calibri"/>
               </a:rPr>
-              <a:t>One frame, one architecture, one strategic relationship</a:t>
+              <a:t>Black Ops: an elite tiger team for the accounts nobody else can crack</a:t>
             </a:r>
           </a:p>
         </p:txBody>
@@ -13005,7 +13952,7 @@
                 </a:solidFill>
                 <a:latin typeface="Calibri"/>
               </a:rPr>
-              <a:t>Siloed: 3 sellers call on 3 managers about 3 disconnected deals</a:t>
+              <a:t>The Field CTO group runs the marathon; Black Ops runs the sprint</a:t>
             </a:r>
           </a:p>
           <a:p>
@@ -13030,7 +13977,7 @@
                 </a:solidFill>
                 <a:latin typeface="Calibri"/>
               </a:rPr>
-              <a:t>X-Arch: one CxO session framed as 'keep cargo moving under attack'</a:t>
+              <a:t>Parachutes into stalled whales / SI-locked / narrow-window accounts</a:t>
             </a:r>
           </a:p>
           <a:p>
@@ -13055,7 +14002,7 @@
                 </a:solidFill>
                 <a:latin typeface="Calibri"/>
               </a:rPr>
-              <a:t>One reference architecture: passive OT + segmentation + SD-WAN + modern SOC</a:t>
+              <a:t>Mission-scoped, time-boxed (60–120 days); breaks the account open, then HANDS BACK</a:t>
             </a:r>
           </a:p>
           <a:p>
@@ -13080,7 +14027,7 @@
                 </a:solidFill>
                 <a:latin typeface="Calibri"/>
               </a:rPr>
-              <a:t>Result: a larger, multi-year program the customer co-authored</a:t>
+              <a:t>Ethical and above-board; all OT-safety and read-only guardrails still apply</a:t>
             </a:r>
           </a:p>
         </p:txBody>
@@ -13220,7 +14167,7 @@
                 </a:solidFill>
                 <a:latin typeface="Calibri"/>
               </a:rPr>
-              <a:t>FOCUS · ARCHITECTURES</a:t>
+              <a:t>IN PRACTICE</a:t>
             </a:r>
           </a:p>
         </p:txBody>
@@ -13302,7 +14249,7 @@
                 </a:solidFill>
                 <a:latin typeface="Calibri"/>
               </a:rPr>
-              <a:t>We lead with the three highest-attach architectures, plus one adjacency</a:t>
+              <a:t>One frame, one architecture, one strategic relationship</a:t>
             </a:r>
           </a:p>
         </p:txBody>
@@ -13395,7 +14342,7 @@
                 </a:solidFill>
                 <a:latin typeface="Calibri"/>
               </a:rPr>
-              <a:t>Secure Networking — Catalyst/Meraki/SD-WAN + Firewall/ISE/XDR/Duo</a:t>
+              <a:t>Siloed: 3 sellers call on 3 managers about 3 disconnected deals</a:t>
             </a:r>
           </a:p>
           <a:p>
@@ -13420,7 +14367,7 @@
                 </a:solidFill>
                 <a:latin typeface="Calibri"/>
               </a:rPr>
-              <a:t>Full-Stack Observability &amp; Data — Splunk, ThousandEyes, AppDynamics</a:t>
+              <a:t>X-Arch: one CxO session framed as 'keep cargo moving under attack'</a:t>
             </a:r>
           </a:p>
           <a:p>
@@ -13445,7 +14392,7 @@
                 </a:solidFill>
                 <a:latin typeface="Calibri"/>
               </a:rPr>
-              <a:t>Resilience &amp; Security Operations — Splunk ES + XDR + SOAR</a:t>
+              <a:t>One reference architecture: passive OT + segmentation + SD-WAN + modern SOC</a:t>
             </a:r>
           </a:p>
           <a:p>
@@ -13470,7 +14417,7 @@
                 </a:solidFill>
                 <a:latin typeface="Calibri"/>
               </a:rPr>
-              <a:t>(+1) AI-Ready Infrastructure — UCS/Nexus/AI PODs as pull-through</a:t>
+              <a:t>Result: a larger, multi-year program the customer co-authored</a:t>
             </a:r>
           </a:p>
         </p:txBody>
@@ -13610,7 +14557,7 @@
                 </a:solidFill>
                 <a:latin typeface="Calibri"/>
               </a:rPr>
-              <a:t>FOCUS · VERTICALS</a:t>
+              <a:t>FOCUS · ARCHITECTURES</a:t>
             </a:r>
           </a:p>
         </p:txBody>
@@ -13692,7 +14639,7 @@
                 </a:solidFill>
                 <a:latin typeface="Calibri"/>
               </a:rPr>
-              <a:t>Four verticals chosen for cross-attach and regulatory pull</a:t>
+              <a:t>We lead with the three highest-attach architectures, plus one adjacency</a:t>
             </a:r>
           </a:p>
         </p:txBody>
@@ -13785,7 +14732,7 @@
                 </a:solidFill>
                 <a:latin typeface="Calibri"/>
               </a:rPr>
-              <a:t>Transportation &amp; Logistics — distributed sites, IoT, transport-OT (NIS2)</a:t>
+              <a:t>Secure Networking — Catalyst/Meraki/SD-WAN + Firewall/ISE/XDR/Duo</a:t>
             </a:r>
           </a:p>
           <a:p>
@@ -13810,7 +14757,7 @@
                 </a:solidFill>
                 <a:latin typeface="Calibri"/>
               </a:rPr>
-              <a:t>Financial Services — resilience (DORA), fraud, SecOps, observability</a:t>
+              <a:t>Full-Stack Observability &amp; Data — Splunk, ThousandEyes, AppDynamics</a:t>
             </a:r>
           </a:p>
           <a:p>
@@ -13835,7 +14782,7 @@
                 </a:solidFill>
                 <a:latin typeface="Calibri"/>
               </a:rPr>
-              <a:t>Healthcare — IoMT security, clinical-app observability, HIPAA</a:t>
+              <a:t>Resilience &amp; Security Operations — Splunk ES + XDR + SOAR</a:t>
             </a:r>
           </a:p>
           <a:p>
@@ -13860,7 +14807,7 @@
                 </a:solidFill>
                 <a:latin typeface="Calibri"/>
               </a:rPr>
-              <a:t>Public Sector / Critical Infrastructure — NERC-CIP/NIS2, SOC modernization</a:t>
+              <a:t>(+1) AI-Ready Infrastructure — UCS/Nexus/AI PODs as pull-through</a:t>
             </a:r>
           </a:p>
         </p:txBody>

</xml_diff>